<commit_message>
2025-08-20 종합설계 2 미팅
</commit_message>
<xml_diff>
--- a/documents/포트폴리오/2020180028_이주형.pptx
+++ b/documents/포트폴리오/2020180028_이주형.pptx
@@ -214,7 +214,7 @@
           <a:p>
             <a:fld id="{C23C6B08-5A15-45B9-88ED-9D405D0D1249}" type="datetimeFigureOut">
               <a:rPr lang="ko-KR" altLang="en-US" smtClean="0"/>
-              <a:t>2025-08-19</a:t>
+              <a:t>2025-08-20</a:t>
             </a:fld>
             <a:endParaRPr lang="ko-KR" altLang="en-US"/>
           </a:p>
@@ -712,7 +712,7 @@
           <a:p>
             <a:fld id="{F7AE3007-875A-4881-99C8-3250DAD1C440}" type="datetimeFigureOut">
               <a:rPr lang="ko-KR" altLang="en-US" smtClean="0"/>
-              <a:t>2025-08-19</a:t>
+              <a:t>2025-08-20</a:t>
             </a:fld>
             <a:endParaRPr lang="ko-KR" altLang="en-US"/>
           </a:p>
@@ -910,7 +910,7 @@
           <a:p>
             <a:fld id="{F7AE3007-875A-4881-99C8-3250DAD1C440}" type="datetimeFigureOut">
               <a:rPr lang="ko-KR" altLang="en-US" smtClean="0"/>
-              <a:t>2025-08-19</a:t>
+              <a:t>2025-08-20</a:t>
             </a:fld>
             <a:endParaRPr lang="ko-KR" altLang="en-US"/>
           </a:p>
@@ -1118,7 +1118,7 @@
           <a:p>
             <a:fld id="{F7AE3007-875A-4881-99C8-3250DAD1C440}" type="datetimeFigureOut">
               <a:rPr lang="ko-KR" altLang="en-US" smtClean="0"/>
-              <a:t>2025-08-19</a:t>
+              <a:t>2025-08-20</a:t>
             </a:fld>
             <a:endParaRPr lang="ko-KR" altLang="en-US"/>
           </a:p>
@@ -1316,7 +1316,7 @@
           <a:p>
             <a:fld id="{F7AE3007-875A-4881-99C8-3250DAD1C440}" type="datetimeFigureOut">
               <a:rPr lang="ko-KR" altLang="en-US" smtClean="0"/>
-              <a:t>2025-08-19</a:t>
+              <a:t>2025-08-20</a:t>
             </a:fld>
             <a:endParaRPr lang="ko-KR" altLang="en-US"/>
           </a:p>
@@ -1591,7 +1591,7 @@
           <a:p>
             <a:fld id="{F7AE3007-875A-4881-99C8-3250DAD1C440}" type="datetimeFigureOut">
               <a:rPr lang="ko-KR" altLang="en-US" smtClean="0"/>
-              <a:t>2025-08-19</a:t>
+              <a:t>2025-08-20</a:t>
             </a:fld>
             <a:endParaRPr lang="ko-KR" altLang="en-US"/>
           </a:p>
@@ -1856,7 +1856,7 @@
           <a:p>
             <a:fld id="{F7AE3007-875A-4881-99C8-3250DAD1C440}" type="datetimeFigureOut">
               <a:rPr lang="ko-KR" altLang="en-US" smtClean="0"/>
-              <a:t>2025-08-19</a:t>
+              <a:t>2025-08-20</a:t>
             </a:fld>
             <a:endParaRPr lang="ko-KR" altLang="en-US"/>
           </a:p>
@@ -2268,7 +2268,7 @@
           <a:p>
             <a:fld id="{F7AE3007-875A-4881-99C8-3250DAD1C440}" type="datetimeFigureOut">
               <a:rPr lang="ko-KR" altLang="en-US" smtClean="0"/>
-              <a:t>2025-08-19</a:t>
+              <a:t>2025-08-20</a:t>
             </a:fld>
             <a:endParaRPr lang="ko-KR" altLang="en-US"/>
           </a:p>
@@ -2409,7 +2409,7 @@
           <a:p>
             <a:fld id="{F7AE3007-875A-4881-99C8-3250DAD1C440}" type="datetimeFigureOut">
               <a:rPr lang="ko-KR" altLang="en-US" smtClean="0"/>
-              <a:t>2025-08-19</a:t>
+              <a:t>2025-08-20</a:t>
             </a:fld>
             <a:endParaRPr lang="ko-KR" altLang="en-US"/>
           </a:p>
@@ -2522,7 +2522,7 @@
           <a:p>
             <a:fld id="{F7AE3007-875A-4881-99C8-3250DAD1C440}" type="datetimeFigureOut">
               <a:rPr lang="ko-KR" altLang="en-US" smtClean="0"/>
-              <a:t>2025-08-19</a:t>
+              <a:t>2025-08-20</a:t>
             </a:fld>
             <a:endParaRPr lang="ko-KR" altLang="en-US"/>
           </a:p>
@@ -2833,7 +2833,7 @@
           <a:p>
             <a:fld id="{F7AE3007-875A-4881-99C8-3250DAD1C440}" type="datetimeFigureOut">
               <a:rPr lang="ko-KR" altLang="en-US" smtClean="0"/>
-              <a:t>2025-08-19</a:t>
+              <a:t>2025-08-20</a:t>
             </a:fld>
             <a:endParaRPr lang="ko-KR" altLang="en-US"/>
           </a:p>
@@ -3121,7 +3121,7 @@
           <a:p>
             <a:fld id="{F7AE3007-875A-4881-99C8-3250DAD1C440}" type="datetimeFigureOut">
               <a:rPr lang="ko-KR" altLang="en-US" smtClean="0"/>
-              <a:t>2025-08-19</a:t>
+              <a:t>2025-08-20</a:t>
             </a:fld>
             <a:endParaRPr lang="ko-KR" altLang="en-US"/>
           </a:p>
@@ -3362,7 +3362,7 @@
           <a:p>
             <a:fld id="{F7AE3007-875A-4881-99C8-3250DAD1C440}" type="datetimeFigureOut">
               <a:rPr lang="ko-KR" altLang="en-US" smtClean="0"/>
-              <a:t>2025-08-19</a:t>
+              <a:t>2025-08-20</a:t>
             </a:fld>
             <a:endParaRPr lang="ko-KR" altLang="en-US"/>
           </a:p>
@@ -4118,7 +4118,7 @@
               <a:buChar char="•"/>
             </a:pPr>
             <a:r>
-              <a:rPr lang="en-US" altLang="ko-KR" sz="1400" dirty="0"/>
+              <a:rPr lang="en-US" altLang="ko-KR" sz="1400" b="1" dirty="0"/>
               <a:t>Rust</a:t>
             </a:r>
           </a:p>
@@ -4206,14 +4206,14 @@
               <a:buChar char="•"/>
             </a:pPr>
             <a:r>
-              <a:rPr lang="en-US" altLang="ko-KR" sz="1400" dirty="0"/>
+              <a:rPr lang="en-US" altLang="ko-KR" sz="1400" b="1" dirty="0"/>
               <a:t>IOCP/</a:t>
             </a:r>
             <a:r>
-              <a:rPr lang="ko-KR" altLang="en-US" sz="1400" dirty="0"/>
+              <a:rPr lang="ko-KR" altLang="en-US" sz="1400" b="1" dirty="0"/>
               <a:t>비동기 프로그래밍</a:t>
             </a:r>
-            <a:endParaRPr lang="en-US" altLang="ko-KR" sz="1400" dirty="0"/>
+            <a:endParaRPr lang="en-US" altLang="ko-KR" sz="1400" b="1" dirty="0"/>
           </a:p>
           <a:p>
             <a:pPr marL="285750" indent="-285750">

</xml_diff>